<commit_message>
Add simplified multi-agent systems deck
Add a static, audience-friendly presentation with speaker notes and a build script. Clarify the LangChain and LangGraph comparison in the existing slides 14–16 deck.
</commit_message>
<xml_diff>
--- a/multi_agent_systems_slide_14_to_16/Slides-14-16.pptx
+++ b/multi_agent_systems_slide_14_to_16/Slides-14-16.pptx
@@ -117,27 +117,27 @@
   <p:extLst>
     <p:ext uri="{521415D9-36F7-43E2-AB2F-B90AF26B5E84}">
       <p14:sectionLst xmlns:p14="http://schemas.microsoft.com/office/powerpoint/2010/main">
-        <p14:section name="14 · Common Mistakes" id="{b2c5637f-5f8b-72af-109c-04b443e4cfcd}">
+        <p14:section name="14 · Common Mistakes" id="{4ea663ca-5188-4960-3f5e-5da2fa0550d3}">
           <p14:sldIdLst>
             <p14:sldId id="256"/>
           </p14:sldIdLst>
         </p14:section>
-        <p14:section name="15 · Choose the Pattern" id="{7d4f336c-0e67-2fcc-22ff-0e329bb0d337}">
+        <p14:section name="15 · Choose the Pattern" id="{134ad31c-1edc-53bd-c0ae-6e8ba9fa9e5d}">
           <p14:sldIdLst>
             <p14:sldId id="257"/>
           </p14:sldIdLst>
         </p14:section>
-        <p14:section name="16 · Design Principles" id="{c040ac64-7300-dd08-bd7b-2f26cf999b0b}">
+        <p14:section name="16 · Design Principles" id="{0d0a824a-2ef6-34d0-6b7c-838273838498}">
           <p14:sldIdLst>
             <p14:sldId id="258"/>
           </p14:sldIdLst>
         </p14:section>
-        <p14:section name="16a · LangChain and LangGraph" id="{062fe80e-44d7-3072-1f49-6b8f87906f1e}">
+        <p14:section name="16a · LangChain and LangGraph" id="{37fd0cd9-ad04-c81a-6610-94b3e07f8e5f}">
           <p14:sldIdLst>
             <p14:sldId id="259"/>
           </p14:sldIdLst>
         </p14:section>
-        <p14:section name="16b · Reading the Graph" id="{6d21e365-8acb-9316-ee42-f076aa0c8322}">
+        <p14:section name="16b · Reading the Graph" id="{f424ed4d-8af5-c59a-5789-660d6c318817}">
           <p14:sldIdLst>
             <p14:sldId id="260"/>
             <p14:sldId id="261"/>
@@ -1003,10 +1003,10 @@
           <a:p>
             <a:r>
               <a:rPr lang="en-US" dirty="0"/>
-              <a:t>Two libraries, two jobs. LangChain gives you the building blocks: a common interface to models, prompts, tools, and structured output, plus create_agent for a ready-made agent loop. LangGraph is the orchestration layer: you describe your system as a graph of nodes sharing a state, and it runs it, with loops, branching, persistence and human-in-the-loop built in.
+              <a:t>Both libraries do the same basic job: they connect AI steps into a workflow, using models, prompts, tools and structured output. The difference is the shape. LangChain runs the steps in a fixed sequence: A, then B, then C, each once. That's ideal for pipelines whose steps never change order. LangGraph connects the steps as a graph of nodes sharing a state, so the work can loop back, branch, run in parallel, save its progress and pause for a human.
 The two core ideas are node and graph. A node is one job: a Python function that reads the state and returns the keys it changed. Edges are the hand-offs. A conditional edge is a router: here the checker's status decides whether we finish or go back to the worker. That's exactly the explicit hand-off from slide 5, replacing the finish_reason if/else.
 The code is the whole thing: a state, two nodes, three edges, compile, invoke. recursion_limit is our bounded execution. And a compiled graph can itself be used as a node, which is how subgraphs work.
-Close: LangChain for the parts, LangGraph for the wiring. Every pattern in this deck is a LangGraph graph.</a:t>
+Close: Both connect the steps: LangChain in a fixed sequence, LangGraph as a graph. Every pattern in this deck is a LangGraph graph.</a:t>
             </a:r>
             <a:endParaRPr lang="en-US" dirty="0"/>
           </a:p>
@@ -11422,7 +11422,7 @@
                 <a:ea typeface="Arial" pitchFamily="34" charset="-122"/>
                 <a:cs typeface="Arial" pitchFamily="34" charset="-120"/>
               </a:rPr>
-              <a:t>LangChain gives you the parts: models, prompts and tools. LangGraph wires them into a graph with one shared state, so loops, checks and human approval are built in.</a:t>
+              <a:t>Both connect AI steps into a workflow. LangChain runs them in a fixed sequence; LangGraph connects them as a graph, so steps can loop, branch and pause for a person.</a:t>
             </a:r>
             <a:endParaRPr lang="en-US" sz="1400" dirty="0"/>
           </a:p>
@@ -11522,7 +11522,7 @@
                 <a:ea typeface="Calibri" pitchFamily="34" charset="-122"/>
                 <a:cs typeface="Calibri" pitchFamily="34" charset="-120"/>
               </a:rPr>
-              <a:t>LangChain · the building blocks</a:t>
+              <a:t>LangChain · sequential chains</a:t>
             </a:r>
             <a:endParaRPr lang="en-US" sz="1500" dirty="0"/>
           </a:p>
@@ -11565,7 +11565,7 @@
                 <a:ea typeface="Calibri" pitchFamily="34" charset="-122"/>
                 <a:cs typeface="Calibri" pitchFamily="34" charset="-120"/>
               </a:rPr>
-              <a:t>One interface for chat models (e.g. ChatGroq, ChatAnthropic)</a:t>
+              <a:t>Steps run in a fixed sequence: A → B → C</a:t>
             </a:r>
             <a:endParaRPr lang="en-US" sz="1250" dirty="0"/>
           </a:p>
@@ -11586,7 +11586,7 @@
                 <a:ea typeface="Calibri" pitchFamily="34" charset="-122"/>
                 <a:cs typeface="Calibri" pitchFamily="34" charset="-120"/>
               </a:rPr>
-              <a:t>Prompts, tools (@tool) and structured output</a:t>
+              <a:t>One interface for chat models (e.g. ChatGroq, ChatAnthropic)</a:t>
             </a:r>
             <a:endParaRPr lang="en-US" sz="1250" dirty="0"/>
           </a:p>
@@ -11607,7 +11607,7 @@
                 <a:ea typeface="Calibri" pitchFamily="34" charset="-122"/>
                 <a:cs typeface="Calibri" pitchFamily="34" charset="-120"/>
               </a:rPr>
-              <a:t>create_agent: a ready-made agent loop</a:t>
+              <a:t>Prompts, tools (@tool) and structured output</a:t>
             </a:r>
             <a:endParaRPr lang="en-US" sz="1250" dirty="0"/>
           </a:p>
@@ -11707,7 +11707,7 @@
                 <a:ea typeface="Calibri" pitchFamily="34" charset="-122"/>
                 <a:cs typeface="Calibri" pitchFamily="34" charset="-120"/>
               </a:rPr>
-              <a:t>LangGraph · the orchestration</a:t>
+              <a:t>LangGraph · graphs</a:t>
             </a:r>
             <a:endParaRPr lang="en-US" sz="1500" dirty="0"/>
           </a:p>
@@ -11750,7 +11750,7 @@
                 <a:ea typeface="Calibri" pitchFamily="34" charset="-122"/>
                 <a:cs typeface="Calibri" pitchFamily="34" charset="-120"/>
               </a:rPr>
-              <a:t>Describe the system as nodes + edges over a shared state</a:t>
+              <a:t>Steps in any order: loops, branches, parallel</a:t>
             </a:r>
             <a:endParaRPr lang="en-US" sz="1250" dirty="0"/>
           </a:p>
@@ -11771,7 +11771,7 @@
                 <a:ea typeface="Calibri" pitchFamily="34" charset="-122"/>
                 <a:cs typeface="Calibri" pitchFamily="34" charset="-120"/>
               </a:rPr>
-              <a:t>Loops and branching (conditional edges)</a:t>
+              <a:t>Nodes + edges over a shared state</a:t>
             </a:r>
             <a:endParaRPr lang="en-US" sz="1250" dirty="0"/>
           </a:p>

</xml_diff>